<commit_message>
v2.35 (John's word, 13 October): Evening 14 - the frame sentence ('From here, the evenings stop holding you, and you start holding the practice'), the last stretch as three evenings, the sending lines; Evening 15's planning lab carries the mercy-card rehearsal
Co-Authored-By: Claude Opus 5.5 <noreply@anthropic.com>
</commit_message>
<xml_diff>
--- a/_implementation-notes/evening-series/FotH Evening Session 18 Slides DRAFT v1.pptx
+++ b/_implementation-notes/evening-series/FotH Evening Session 18 Slides DRAFT v1.pptx
@@ -1357,12 +1357,12 @@
           </a:p>
           <a:p>
             <a:r>
-              <a:t>1. Write the five lines live on the whiteboard, saying each: Wk 19 the teens teach the two mercy cards in pairs; Wk 20 The Long Walk — the seniors teach the whole room, journals come; Wk 21 Sending and Blessing — whole families, a TWO-HOUR night; Wk 22 the Commissioning of the Companions.</a:t>
-            </a:r>
-          </a:p>
-          <a:p>
-            <a:r>
-              <a:t>2. Land the frame sentence: the year now begins to hand itself over — that was always the plan.</a:t>
+              <a:t>1. Write the three lines live on the whiteboard, saying each: Evening 15, The Long Walk — the Companions-in-Formation teach the two mercy cards, journals come; Evening 16, Sending and Blessing — whole families, a TWO-HOUR night; Evening 17, the Commissioning of the Companions.</a:t>
+            </a:r>
+          </a:p>
+          <a:p>
+            <a:r>
+              <a:t>2. Land the frame sentence (John's word, 13 October): 'From here, the evenings stop holding you, and you start holding the practice.' The teens have led from the first night; what steps back now is the structure, and that was always the plan.</a:t>
             </a:r>
           </a:p>
           <a:p>
@@ -1651,7 +1651,7 @@
           </a:p>
           <a:p>
             <a:r>
-              <a:t>1. One sentence for the road: you came back like people who know the way — five weeks to the sending; the season is His, and it is nearly harvest.</a:t>
+              <a:t>1. One sentence for the road: you came back like people who know the way — two evenings to the sending; the season is His, and it is nearly harvest.</a:t>
             </a:r>
           </a:p>
           <a:p>
@@ -1661,7 +1661,7 @@
           </a:p>
           <a:p>
             <a:r>
-              <a:t>3. Send them glad: see you evenings — Week 19, the teens have the cards.</a:t>
+              <a:t>3. Send them glad: see you in two weeks — Evening 15, the teens have the cards.</a:t>
             </a:r>
           </a:p>
         </p:txBody>
@@ -6150,7 +6150,7 @@
                 </a:solidFill>
                 <a:latin typeface="Calibri"/>
               </a:rPr>
-              <a:t>“Five weeks to the sending. Let us not grow weary; the season is His, and it is nearly harvest.”</a:t>
+              <a:t>“Two evenings to the sending. Let us not grow weary; the season is His, and it is nearly harvest.”</a:t>
             </a:r>
           </a:p>
           <a:p>
@@ -6175,7 +6175,7 @@
                 </a:solidFill>
                 <a:latin typeface="Calibri"/>
               </a:rPr>
-              <a:t>“See you Wednesday. Week 19 — the teens have the cards.”</a:t>
+              <a:t>“See you in two weeks — Evening 15. The teens have the cards.”</a:t>
             </a:r>
           </a:p>
         </p:txBody>
@@ -6440,7 +6440,7 @@
                 </a:solidFill>
                 <a:latin typeface="Calibri"/>
               </a:rPr>
-              <a:t>A lighter homecoming — the room knows the way now, and the year begins to hand itself over</a:t>
+              <a:t>A lighter homecoming — the room knows the way now, and from here the practice is yours to hold</a:t>
             </a:r>
           </a:p>
         </p:txBody>
@@ -8286,7 +8286,7 @@
                 </a:solidFill>
                 <a:latin typeface="Calibri"/>
               </a:rPr>
-              <a:t>Week 19 — our Companions-in-Formation teach the two mercy cards — the Signs Card and the Path Home Card — in your pairs</a:t>
+              <a:t>Evening 15 — The Long Walk: our Companions-in-Formation teach the two mercy cards, the Signs Card and the Path Home Card; journals come along, and the testimony gathering begins</a:t>
             </a:r>
           </a:p>
           <a:p>
@@ -8311,7 +8311,7 @@
                 </a:solidFill>
                 <a:latin typeface="Calibri"/>
               </a:rPr>
-              <a:t>Evening 15 — The Long Walk: the seniors teach the whole room; journals come along, and the testimony gathering begins</a:t>
+              <a:t>Evening 16 — Sending and Blessing: whole families, a longer evening — two hours, 6:30 to 8:30</a:t>
             </a:r>
           </a:p>
           <a:p>
@@ -8336,31 +8336,6 @@
                 </a:solidFill>
                 <a:latin typeface="Calibri"/>
               </a:rPr>
-              <a:t>Evening 16 — Sending and Blessing: whole families, a longer evening — two hours, 6:30 to 8:30</a:t>
-            </a:r>
-          </a:p>
-          <a:p>
-            <a:pPr marL="342900" indent="-342900">
-              <a:spcAft>
-                <a:spcPts val="750"/>
-              </a:spcAft>
-            </a:pPr>
-            <a:r>
-              <a:rPr sz="2400" b="1" i="0">
-                <a:solidFill>
-                  <a:srgbClr val="97BC62"/>
-                </a:solidFill>
-                <a:latin typeface="Calibri"/>
-              </a:rPr>
-              <a:t>4   </a:t>
-            </a:r>
-            <a:r>
-              <a:rPr sz="2400" b="0" i="0">
-                <a:solidFill>
-                  <a:srgbClr val="222B22"/>
-                </a:solidFill>
-                <a:latin typeface="Calibri"/>
-              </a:rPr>
               <a:t>Evening 17 — the Commissioning of the Companions, in front of everybody who watched them grow</a:t>
             </a:r>
           </a:p>
@@ -8386,7 +8361,7 @@
                 </a:solidFill>
                 <a:latin typeface="Calibri"/>
               </a:rPr>
-              <a:t>Hear the shape of that list: week by week, the people up front stop being us and start being you</a:t>
+              <a:t>Evening by evening, the structure steps back, and the practice stays with you</a:t>
             </a:r>
           </a:p>
           <a:p>
@@ -8411,7 +8386,7 @@
                 </a:solidFill>
                 <a:latin typeface="Calibri"/>
               </a:rPr>
-              <a:t>The sentence to keep: “the year now begins to hand itself over”</a:t>
+              <a:t>The sentence to keep: “From here, the evenings stop holding you, and you start holding the practice.”</a:t>
             </a:r>
           </a:p>
         </p:txBody>

</xml_diff>

<commit_message>
v2.36 (John's word, 13 October): Evening 14 - Ready, and Not Yet (everyone, parents first); the invitation list for the follow-up series in the homework and preparation sentence; master pages from Evening 14 on +1 (324)
Co-Authored-By: Claude Opus 5.5 <noreply@anthropic.com>
</commit_message>
<xml_diff>
--- a/_implementation-notes/evening-series/FotH Evening Session 18 Slides DRAFT v1.pptx
+++ b/_implementation-notes/evening-series/FotH Evening Session 18 Slides DRAFT v1.pptx
@@ -16,6 +16,7 @@
     <p:sldId id="476" r:id="rId224"/>
     <p:sldId id="477" r:id="rId225"/>
     <p:sldId id="478" r:id="rId226"/>
+    <p:sldId id="545" r:id="rId20"/>
     <p:sldId id="479" r:id="rId227"/>
     <p:sldId id="543" r:id="rId22"/>
     <p:sldId id="544" r:id="rId23"/>
@@ -751,6 +752,72 @@
 </p:notes>
 </file>
 
+<file path=ppt/notesSlides/notesSlide12.xml><?xml version="1.0" encoding="utf-8"?>
+<p:notes xmlns:a="http://schemas.openxmlformats.org/drawingml/2006/main" xmlns:p="http://schemas.openxmlformats.org/presentationml/2006/main" xmlns:r="http://schemas.openxmlformats.org/officeDocument/2006/relationships">
+  <p:cSld>
+    <p:spTree>
+      <p:nvGrpSpPr>
+        <p:cNvPr id="1" name=""/>
+        <p:cNvGrpSpPr/>
+        <p:nvPr/>
+      </p:nvGrpSpPr>
+      <p:grpSpPr>
+        <a:xfrm>
+          <a:off x="0" y="0"/>
+          <a:ext cx="0" cy="0"/>
+          <a:chOff x="0" y="0"/>
+          <a:chExt cx="0" cy="0"/>
+        </a:xfrm>
+      </p:grpSpPr>
+      <p:sp>
+        <p:nvSpPr>
+          <p:cNvPr id="2" name="Notes Placeholder 1"/>
+          <p:cNvSpPr>
+            <a:spLocks noGrp="1"/>
+          </p:cNvSpPr>
+          <p:nvPr>
+            <p:ph type="body" idx="1"/>
+          </p:nvPr>
+        </p:nvSpPr>
+        <p:spPr/>
+        <p:txBody>
+          <a:bodyPr/>
+          <a:lstStyle/>
+          <a:p>
+            <a:r>
+              <a:t>E14 · 8:08–8:20 · LEAD: CONTENT PRESENTER CIRCLE</a:t>
+            </a:r>
+          </a:p>
+          <a:p>
+            <a:r>
+              <a:t>BEATS: 1. Bridge from the sentence: 'If the evenings stop holding you, what can you hold now? Where do you still need someone?' 2. Write, 3 minutes, all three questions: what can I do now, on my own, that I couldn't when we started? where do I still need someone beside me — a parent, an adult, this group? what would help me move one 'not yet' toward ready before we are sent? 3. Pairs within families, 6 minutes: the parent answers first — parents tell first. Then the parent names one place they see their teen ready, and one place they still want to walk beside them. 4. Room round, 3 minutes: one 'ready' each, out loud; a parent begins. The 'not yets' stay in the pair.</a:t>
+            </a:r>
+          </a:p>
+          <a:p>
+            <a:r>
+              <a:t>CUES: Never cold-call a teen; pass-anytime holds. The shrinking answer to 'where do I still need an adult?' is the measure the room has been watching since the Session 6 leader questions; say so lightly, once.</a:t>
+            </a:r>
+          </a:p>
+          <a:p>
+            <a:r>
+              <a:t>GUARD: 'Not yet' is honest, never a failure. This is about practices and leading, not anyone's standing with God. Nothing is written down by the team and nothing is graded; it is the room reading itself. A 'not yet' that is heavy gets a follow-up within the week, not a fix tonight.</a:t>
+            </a:r>
+          </a:p>
+          <a:p>
+            <a:r>
+              <a:t>FROM: John's word, 13 October; the S6 leader questions ('Can you do things now you couldn't in August?' 'Where do you still need an adult?') and the 13 October dinner sheet.</a:t>
+            </a:r>
+          </a:p>
+        </p:txBody>
+      </p:sp>
+    </p:spTree>
+  </p:cSld>
+  <p:clrMapOvr>
+    <a:masterClrMapping/>
+  </p:clrMapOvr>
+</p:notes>
+</file>
+
 <file path=ppt/notesSlides/notesSlide13.xml><?xml version="1.0" encoding="utf-8"?>
 <p:notes xmlns:a="http://schemas.openxmlformats.org/drawingml/2006/main" xmlns:p="http://schemas.openxmlformats.org/presentationml/2006/main" xmlns:r="http://schemas.openxmlformats.org/officeDocument/2006/relationships">
   <p:cSld>
@@ -1347,7 +1414,7 @@
           <a:lstStyle/>
           <a:p>
             <a:r>
-              <a:t>E14 · 8:01–8:20 · LEAD: CONTENT PRESENTER CIRCLE</a:t>
+              <a:t>E14 · 8:01–8:08 · LEAD: CONTENT PRESENTER CIRCLE</a:t>
             </a:r>
           </a:p>
           <a:p>
@@ -1367,7 +1434,7 @@
           </a:p>
           <a:p>
             <a:r>
-              <a:t>3. Three asks: come, bring your journal, bring the whole family to Evening 16 — calendar it today, date visible on the board.</a:t>
+              <a:t>3. Keep it to seven minutes; Ready, and Not Yet follows. 4. Three asks: come, bring your journal, bring the whole family to Evening 16 — calendar it today, date visible on the board.</a:t>
             </a:r>
           </a:p>
           <a:p>
@@ -1443,7 +1510,7 @@
           </a:p>
           <a:p>
             <a:r>
-              <a:t>3. The Four Questions word to parents — one paragraph, spoken to the middle distance, moved past without pausing for reaction: willing-only, not-yet counts, nobody checks.</a:t>
+              <a:t>3. The invitation list (John's word, 13 October): start a list of who you would invite to the follow-up series — names, not categories; pray over it before asking anyone. The group decides together, after Evening 17, what the follow-up is; the list is how each family comes ready to that conversation. Names stay in journals; nobody is asked to say them tonight, and the team keeps no list. 4. The Four Questions word to parents — one paragraph, spoken to the middle distance, moved past without pausing for reaction: willing-only, not-yet counts, nobody checks.</a:t>
             </a:r>
           </a:p>
           <a:p>
@@ -4874,6 +4941,314 @@
 </file>
 
 <file path=ppt/slides/slide10.xml><?xml version="1.0" encoding="utf-8"?>
+<p:sld xmlns:a="http://schemas.openxmlformats.org/drawingml/2006/main" xmlns:r="http://schemas.openxmlformats.org/officeDocument/2006/relationships" xmlns:p="http://schemas.openxmlformats.org/presentationml/2006/main">
+  <p:cSld>
+    <p:spTree>
+      <p:nvGrpSpPr>
+        <p:cNvPr id="1" name=""/>
+        <p:cNvGrpSpPr/>
+        <p:nvPr/>
+      </p:nvGrpSpPr>
+      <p:grpSpPr>
+        <a:xfrm>
+          <a:off x="0" y="0"/>
+          <a:ext cx="0" cy="0"/>
+          <a:chOff x="0" y="0"/>
+          <a:chExt cx="0" cy="0"/>
+        </a:xfrm>
+      </p:grpSpPr>
+      <p:sp>
+        <p:nvSpPr>
+          <p:cNvPr id="2" name="Rectangle 1"/>
+          <p:cNvSpPr/>
+          <p:nvPr/>
+        </p:nvSpPr>
+        <p:spPr>
+          <a:xfrm>
+            <a:off x="0" y="0"/>
+            <a:ext cx="12191695" cy="6858000"/>
+          </a:xfrm>
+          <a:prstGeom prst="rect">
+            <a:avLst/>
+          </a:prstGeom>
+          <a:solidFill>
+            <a:srgbClr val="FFFFFF"/>
+          </a:solidFill>
+          <a:ln>
+            <a:noFill/>
+          </a:ln>
+        </p:spPr>
+        <p:txBody>
+          <a:bodyPr/>
+          <a:lstStyle/>
+          <a:p>
+            <a:endParaRPr/>
+          </a:p>
+        </p:txBody>
+      </p:sp>
+      <p:sp>
+        <p:nvSpPr>
+          <p:cNvPr id="3" name="TextBox 2"/>
+          <p:cNvSpPr txBox="1"/>
+          <p:nvPr/>
+        </p:nvSpPr>
+        <p:spPr>
+          <a:xfrm>
+            <a:off x="822960" y="502920"/>
+            <a:ext cx="10515600" cy="822960"/>
+          </a:xfrm>
+          <a:prstGeom prst="rect">
+            <a:avLst/>
+          </a:prstGeom>
+          <a:noFill/>
+        </p:spPr>
+        <p:txBody>
+          <a:bodyPr wrap="square">
+            <a:spAutoFit/>
+          </a:bodyPr>
+          <a:lstStyle/>
+          <a:p>
+            <a:pPr algn="l">
+              <a:spcAft>
+                <a:spcPts val="600"/>
+              </a:spcAft>
+            </a:pPr>
+            <a:r>
+              <a:rPr sz="2800" b="1" i="0">
+                <a:solidFill>
+                  <a:srgbClr val="2C5F2D"/>
+                </a:solidFill>
+                <a:latin typeface="Cambria"/>
+              </a:rPr>
+              <a:t>Homework — Two Weeks, Four Parts</a:t>
+            </a:r>
+          </a:p>
+        </p:txBody>
+      </p:sp>
+      <p:sp>
+        <p:nvSpPr>
+          <p:cNvPr id="4" name="TextBox 4"/>
+          <p:cNvSpPr txBox="1"/>
+          <p:nvPr/>
+        </p:nvSpPr>
+        <p:spPr>
+          <a:xfrm>
+            <a:off x="822960" y="1554480"/>
+            <a:ext cx="6675120" cy="4892040"/>
+          </a:xfrm>
+          <a:prstGeom prst="rect">
+            <a:avLst/>
+          </a:prstGeom>
+          <a:noFill/>
+        </p:spPr>
+        <p:txBody>
+          <a:bodyPr wrap="square" lIns="91440" tIns="91440" rIns="91440" bIns="91440"/>
+          <a:lstStyle/>
+          <a:p>
+            <a:pPr marL="274320" indent="-274320">
+              <a:spcAft>
+                <a:spcPts val="900"/>
+              </a:spcAft>
+            </a:pPr>
+            <a:r>
+              <a:rPr sz="2000" b="1" i="0">
+                <a:solidFill>
+                  <a:srgbClr val="97BC62"/>
+                </a:solidFill>
+                <a:latin typeface="Calibri"/>
+              </a:rPr>
+              <a:t>•  </a:t>
+            </a:r>
+            <a:r>
+              <a:rPr sz="2000" b="0" i="0">
+                <a:solidFill>
+                  <a:srgbClr val="222B22"/>
+                </a:solidFill>
+                <a:latin typeface="Calibri"/>
+              </a:rPr>
+              <a:t>Run your Rhythm Card as built — nothing new, nothing extra; if the break knocked a piece loose, begin again on the next available day</a:t>
+            </a:r>
+          </a:p>
+          <a:p>
+            <a:pPr marL="274320" indent="-274320">
+              <a:spcAft>
+                <a:spcPts val="900"/>
+              </a:spcAft>
+            </a:pPr>
+            <a:r>
+              <a:rPr sz="2000" b="1" i="0">
+                <a:solidFill>
+                  <a:srgbClr val="97BC62"/>
+                </a:solidFill>
+                <a:latin typeface="Calibri"/>
+              </a:rPr>
+              <a:t>•  </a:t>
+            </a:r>
+            <a:r>
+              <a:rPr sz="2000" b="0" i="0">
+                <a:solidFill>
+                  <a:srgbClr val="222B22"/>
+                </a:solidFill>
+                <a:latin typeface="Calibri"/>
+              </a:rPr>
+              <a:t>The evening note, one extra flavor: note where you see God already handing pieces of this year over to you</a:t>
+            </a:r>
+          </a:p>
+          <a:p>
+            <a:pPr marL="274320" indent="-274320">
+              <a:spcAft>
+                <a:spcPts val="900"/>
+              </a:spcAft>
+            </a:pPr>
+            <a:r>
+              <a:rPr sz="2000" b="1" i="0">
+                <a:solidFill>
+                  <a:srgbClr val="97BC62"/>
+                </a:solidFill>
+                <a:latin typeface="Calibri"/>
+              </a:rPr>
+              <a:t>•  </a:t>
+            </a:r>
+            <a:r>
+              <a:rPr sz="2000" b="0" i="0">
+                <a:solidFill>
+                  <a:srgbClr val="222B22"/>
+                </a:solidFill>
+                <a:latin typeface="Calibri"/>
+              </a:rPr>
+              <a:t>Start a list: who would you invite to the follow-up series? Names, not categories. Pray over it before you ask</a:t>
+            </a:r>
+          </a:p>
+          <a:p>
+            <a:pPr marL="274320" indent="-274320">
+              <a:spcAft>
+                <a:spcPts val="900"/>
+              </a:spcAft>
+            </a:pPr>
+            <a:r>
+              <a:rPr sz="2000" b="1" i="0">
+                <a:solidFill>
+                  <a:srgbClr val="97BC62"/>
+                </a:solidFill>
+                <a:latin typeface="Calibri"/>
+              </a:rPr>
+              <a:t>•  </a:t>
+            </a:r>
+            <a:r>
+              <a:rPr sz="2000" b="0" i="0">
+                <a:solidFill>
+                  <a:srgbClr val="222B22"/>
+                </a:solidFill>
+                <a:latin typeface="Calibri"/>
+              </a:rPr>
+              <a:t>For the parents, said once: the Four Questions door is still open — willing-only, whenever the moment is right; nobody will ever check. The questions keep</a:t>
+            </a:r>
+          </a:p>
+          <a:p>
+            <a:pPr marL="274320" indent="-274320">
+              <a:spcAft>
+                <a:spcPts val="900"/>
+              </a:spcAft>
+            </a:pPr>
+            <a:r>
+              <a:rPr sz="2000" b="1" i="0">
+                <a:solidFill>
+                  <a:srgbClr val="97BC62"/>
+                </a:solidFill>
+                <a:latin typeface="Calibri"/>
+              </a:rPr>
+              <a:t>•  </a:t>
+            </a:r>
+            <a:r>
+              <a:rPr sz="2000" b="0" i="0">
+                <a:solidFill>
+                  <a:srgbClr val="222B22"/>
+                </a:solidFill>
+                <a:latin typeface="Calibri"/>
+              </a:rPr>
+              <a:t>Bring your journal — and put Evening 16's two hours on the calendar tonight</a:t>
+            </a:r>
+          </a:p>
+        </p:txBody>
+      </p:sp>
+      <p:sp>
+        <p:nvSpPr>
+          <p:cNvPr id="90" name="SlideNum"/>
+          <p:cNvSpPr txBox="1"/>
+          <p:nvPr/>
+        </p:nvSpPr>
+        <p:spPr>
+          <a:xfrm>
+            <a:off x="11384280" y="6446520"/>
+            <a:ext cx="640080" cy="292608"/>
+          </a:xfrm>
+          <a:prstGeom prst="rect">
+            <a:avLst/>
+          </a:prstGeom>
+          <a:noFill/>
+        </p:spPr>
+        <p:txBody>
+          <a:bodyPr wrap="none" lIns="0" tIns="0" rIns="45720" bIns="0" anchor="ctr"/>
+          <a:lstStyle/>
+          <a:p>
+            <a:pPr algn="r"/>
+            <a:r>
+              <a:t>264</a:t>
+            </a:r>
+            <a:endParaRPr sz="1000" b="1">
+              <a:solidFill>
+                <a:srgbClr val="7A8A6E"/>
+              </a:solidFill>
+              <a:latin typeface="Calibri"/>
+            </a:endParaRPr>
+          </a:p>
+        </p:txBody>
+      </p:sp>
+      <p:pic>
+        <p:nvPicPr>
+          <p:cNvPr id="33" name="Picture 33" descr="seedling - what grows between Wednesdays"/>
+          <p:cNvPicPr>
+            <a:picLocks noChangeAspect="1"/>
+          </p:cNvPicPr>
+          <p:nvPr/>
+        </p:nvPicPr>
+        <p:blipFill>
+          <a:blip r:embed="rId3"/>
+          <a:stretch>
+            <a:fillRect/>
+          </a:stretch>
+        </p:blipFill>
+        <p:spPr>
+          <a:xfrm>
+            <a:off x="8103612" y="1463040"/>
+            <a:ext cx="3262379" cy="4892040"/>
+          </a:xfrm>
+          <a:prstGeom prst="rect">
+            <a:avLst/>
+          </a:prstGeom>
+          <a:ln w="76200">
+            <a:solidFill>
+              <a:srgbClr val="FFFFFF"/>
+            </a:solidFill>
+          </a:ln>
+          <a:effectLst>
+            <a:outerShdw blurRad="63500" dist="25400" dir="5400000" rotWithShape="0">
+              <a:srgbClr val="000000">
+                <a:alpha val="35000"/>
+              </a:srgbClr>
+            </a:outerShdw>
+          </a:effectLst>
+        </p:spPr>
+      </p:pic>
+    </p:spTree>
+  </p:cSld>
+  <p:clrMapOvr>
+    <a:masterClrMapping/>
+  </p:clrMapOvr>
+</p:sld>
+</file>
+
+<file path=ppt/slides/slide11.xml><?xml version="1.0" encoding="utf-8"?>
 <p:sld xmlns:a="http://schemas.openxmlformats.org/drawingml/2006/main" xmlns:p="http://schemas.openxmlformats.org/presentationml/2006/main" xmlns:r="http://schemas.openxmlformats.org/officeDocument/2006/relationships">
   <p:cSld>
     <p:spTree>
@@ -5046,7 +5421,7 @@
           <a:p>
             <a:pPr algn="r"/>
             <a:r>
-              <a:t>264</a:t>
+              <a:t>265</a:t>
             </a:r>
             <a:endParaRPr sz="1000" b="1">
               <a:solidFill>
@@ -5065,7 +5440,7 @@
 </p:sld>
 </file>
 
-<file path=ppt/slides/slide11.xml><?xml version="1.0" encoding="utf-8"?>
+<file path=ppt/slides/slide12.xml><?xml version="1.0" encoding="utf-8"?>
 <p:sld xmlns:a="http://schemas.openxmlformats.org/drawingml/2006/main" xmlns:p="http://schemas.openxmlformats.org/presentationml/2006/main" xmlns:r="http://schemas.openxmlformats.org/officeDocument/2006/relationships">
   <p:cSld>
     <p:spTree>
@@ -5238,415 +5613,6 @@
           <a:p>
             <a:pPr algn="r"/>
             <a:r>
-              <a:t>265</a:t>
-            </a:r>
-            <a:endParaRPr sz="1000" b="1">
-              <a:solidFill>
-                <a:srgbClr val="7A8A6E"/>
-              </a:solidFill>
-              <a:latin typeface="Calibri"/>
-            </a:endParaRPr>
-          </a:p>
-        </p:txBody>
-      </p:sp>
-    </p:spTree>
-  </p:cSld>
-  <p:clrMapOvr>
-    <a:masterClrMapping/>
-  </p:clrMapOvr>
-</p:sld>
-</file>
-
-<file path=ppt/slides/slide12.xml><?xml version="1.0" encoding="utf-8"?>
-<p:sld xmlns:a="http://schemas.openxmlformats.org/drawingml/2006/main" xmlns:r="http://schemas.openxmlformats.org/officeDocument/2006/relationships" xmlns:p="http://schemas.openxmlformats.org/presentationml/2006/main">
-  <p:cSld>
-    <p:spTree>
-      <p:nvGrpSpPr>
-        <p:cNvPr id="1" name=""/>
-        <p:cNvGrpSpPr/>
-        <p:nvPr/>
-      </p:nvGrpSpPr>
-      <p:grpSpPr>
-        <a:xfrm>
-          <a:off x="0" y="0"/>
-          <a:ext cx="0" cy="0"/>
-          <a:chOff x="0" y="0"/>
-          <a:chExt cx="0" cy="0"/>
-        </a:xfrm>
-      </p:grpSpPr>
-      <p:sp>
-        <p:nvSpPr>
-          <p:cNvPr id="2" name="Rectangle 1"/>
-          <p:cNvSpPr/>
-          <p:nvPr/>
-        </p:nvSpPr>
-        <p:spPr>
-          <a:xfrm>
-            <a:off x="0" y="0"/>
-            <a:ext cx="12191695" cy="6858000"/>
-          </a:xfrm>
-          <a:prstGeom prst="rect">
-            <a:avLst/>
-          </a:prstGeom>
-          <a:solidFill>
-            <a:srgbClr val="FFFFFF"/>
-          </a:solidFill>
-          <a:ln>
-            <a:noFill/>
-          </a:ln>
-        </p:spPr>
-        <p:txBody>
-          <a:bodyPr/>
-          <a:lstStyle/>
-          <a:p>
-            <a:endParaRPr/>
-          </a:p>
-        </p:txBody>
-      </p:sp>
-      <p:sp>
-        <p:nvSpPr>
-          <p:cNvPr id="3" name="TextBox 2"/>
-          <p:cNvSpPr txBox="1"/>
-          <p:nvPr/>
-        </p:nvSpPr>
-        <p:spPr>
-          <a:xfrm>
-            <a:off x="822960" y="502920"/>
-            <a:ext cx="10515600" cy="822960"/>
-          </a:xfrm>
-          <a:prstGeom prst="rect">
-            <a:avLst/>
-          </a:prstGeom>
-          <a:noFill/>
-        </p:spPr>
-        <p:txBody>
-          <a:bodyPr wrap="square">
-            <a:spAutoFit/>
-          </a:bodyPr>
-          <a:lstStyle/>
-          <a:p>
-            <a:pPr algn="l">
-              <a:spcAft>
-                <a:spcPts val="600"/>
-              </a:spcAft>
-            </a:pPr>
-            <a:r>
-              <a:rPr sz="2800" b="1" i="0">
-                <a:solidFill>
-                  <a:srgbClr val="2C5F2D"/>
-                </a:solidFill>
-                <a:latin typeface="Cambria"/>
-              </a:rPr>
-              <a:t>Closing the Container + Aaronic Blessing</a:t>
-            </a:r>
-          </a:p>
-        </p:txBody>
-      </p:sp>
-      <p:sp>
-        <p:nvSpPr>
-          <p:cNvPr id="4" name="TextBox 4"/>
-          <p:cNvSpPr txBox="1"/>
-          <p:nvPr/>
-        </p:nvSpPr>
-        <p:spPr>
-          <a:xfrm>
-            <a:off x="822960" y="1600200"/>
-            <a:ext cx="5669280" cy="4572000"/>
-          </a:xfrm>
-          <a:prstGeom prst="rect">
-            <a:avLst/>
-          </a:prstGeom>
-          <a:noFill/>
-        </p:spPr>
-        <p:txBody>
-          <a:bodyPr wrap="square" lIns="91440" tIns="91440" rIns="91440" bIns="91440"/>
-          <a:lstStyle/>
-          <a:p>
-            <a:pPr marL="274320" indent="-274320">
-              <a:spcAft>
-                <a:spcPts val="900"/>
-              </a:spcAft>
-            </a:pPr>
-            <a:r>
-              <a:rPr sz="2200" b="1" i="0">
-                <a:solidFill>
-                  <a:srgbClr val="97BC62"/>
-                </a:solidFill>
-                <a:latin typeface="Calibri"/>
-              </a:rPr>
-              <a:t>•  </a:t>
-            </a:r>
-            <a:r>
-              <a:rPr sz="2200" b="0" i="0">
-                <a:solidFill>
-                  <a:srgbClr val="222B22"/>
-                </a:solidFill>
-                <a:latin typeface="Calibri"/>
-              </a:rPr>
-              <a:t>We close the way we opened — the container, six steps:</a:t>
-            </a:r>
-          </a:p>
-          <a:p>
-            <a:pPr marL="685800" indent="-274320">
-              <a:spcAft>
-                <a:spcPts val="700"/>
-              </a:spcAft>
-            </a:pPr>
-            <a:r>
-              <a:rPr sz="2000" b="1" i="0">
-                <a:solidFill>
-                  <a:srgbClr val="97BC62"/>
-                </a:solidFill>
-                <a:latin typeface="Calibri"/>
-              </a:rPr>
-              <a:t>1   </a:t>
-            </a:r>
-            <a:r>
-              <a:rPr sz="2000" b="0" i="0">
-                <a:solidFill>
-                  <a:srgbClr val="222B22"/>
-                </a:solidFill>
-                <a:latin typeface="Calibri"/>
-              </a:rPr>
-              <a:t>Stand again — same circle, same posture as the open</a:t>
-            </a:r>
-          </a:p>
-          <a:p>
-            <a:pPr marL="685800" indent="-274320">
-              <a:spcAft>
-                <a:spcPts val="700"/>
-              </a:spcAft>
-            </a:pPr>
-            <a:r>
-              <a:rPr sz="2000" b="1" i="0">
-                <a:solidFill>
-                  <a:srgbClr val="97BC62"/>
-                </a:solidFill>
-                <a:latin typeface="Calibri"/>
-              </a:rPr>
-              <a:t>2   </a:t>
-            </a:r>
-            <a:r>
-              <a:rPr sz="2000" b="0" i="0">
-                <a:solidFill>
-                  <a:srgbClr val="222B22"/>
-                </a:solidFill>
-                <a:latin typeface="Calibri"/>
-              </a:rPr>
-              <a:t>One-word landing — compare it to your opening word</a:t>
-            </a:r>
-          </a:p>
-          <a:p>
-            <a:pPr marL="685800" indent="-274320">
-              <a:spcAft>
-                <a:spcPts val="700"/>
-              </a:spcAft>
-            </a:pPr>
-            <a:r>
-              <a:rPr sz="2000" b="1" i="0">
-                <a:solidFill>
-                  <a:srgbClr val="97BC62"/>
-                </a:solidFill>
-                <a:latin typeface="Calibri"/>
-              </a:rPr>
-              <a:t>3   </a:t>
-            </a:r>
-            <a:r>
-              <a:rPr sz="2000" b="0" i="0">
-                <a:solidFill>
-                  <a:srgbClr val="222B22"/>
-                </a:solidFill>
-                <a:latin typeface="Calibri"/>
-              </a:rPr>
-              <a:t>The one thing you are taking from tonight</a:t>
-            </a:r>
-          </a:p>
-          <a:p>
-            <a:pPr marL="685800" indent="-274320">
-              <a:spcAft>
-                <a:spcPts val="700"/>
-              </a:spcAft>
-            </a:pPr>
-            <a:r>
-              <a:rPr sz="2000" b="1" i="0">
-                <a:solidFill>
-                  <a:srgbClr val="97BC62"/>
-                </a:solidFill>
-                <a:latin typeface="Calibri"/>
-              </a:rPr>
-              <a:t>4   </a:t>
-            </a:r>
-            <a:r>
-              <a:rPr sz="2000" b="0" i="0">
-                <a:solidFill>
-                  <a:srgbClr val="222B22"/>
-                </a:solidFill>
-                <a:latin typeface="Calibri"/>
-              </a:rPr>
-              <a:t>The one practice — committed aloud, or modified to one you will actually keep</a:t>
-            </a:r>
-          </a:p>
-          <a:p>
-            <a:pPr marL="685800" indent="-274320">
-              <a:spcAft>
-                <a:spcPts val="700"/>
-              </a:spcAft>
-            </a:pPr>
-            <a:r>
-              <a:rPr sz="2000" b="1" i="0">
-                <a:solidFill>
-                  <a:srgbClr val="97BC62"/>
-                </a:solidFill>
-                <a:latin typeface="Calibri"/>
-              </a:rPr>
-              <a:t>5   </a:t>
-            </a:r>
-            <a:r>
-              <a:rPr sz="2000" b="0" i="0">
-                <a:solidFill>
-                  <a:srgbClr val="222B22"/>
-                </a:solidFill>
-                <a:latin typeface="Calibri"/>
-              </a:rPr>
-              <a:t>Blessings — eyes on the person, not the screen: say what is on your heart for them. Specific, witnessed, short</a:t>
-            </a:r>
-          </a:p>
-          <a:p>
-            <a:pPr marL="685800" indent="-274320">
-              <a:spcAft>
-                <a:spcPts val="700"/>
-              </a:spcAft>
-            </a:pPr>
-            <a:r>
-              <a:rPr sz="2000" b="1" i="0">
-                <a:solidFill>
-                  <a:srgbClr val="97BC62"/>
-                </a:solidFill>
-                <a:latin typeface="Calibri"/>
-              </a:rPr>
-              <a:t>6   </a:t>
-            </a:r>
-            <a:r>
-              <a:rPr sz="2000" b="0" i="0">
-                <a:solidFill>
-                  <a:srgbClr val="222B22"/>
-                </a:solidFill>
-                <a:latin typeface="Calibri"/>
-              </a:rPr>
-              <a:t>Closing prayer — and the Aaronic blessing, spoken over each other, face to face</a:t>
-            </a:r>
-          </a:p>
-        </p:txBody>
-      </p:sp>
-      <p:sp>
-        <p:nvSpPr>
-          <p:cNvPr id="6" name="TextBox 6"/>
-          <p:cNvSpPr txBox="1"/>
-          <p:nvPr/>
-        </p:nvSpPr>
-        <p:spPr>
-          <a:xfrm>
-            <a:off x="6766560" y="1737360"/>
-            <a:ext cx="4663440" cy="2926080"/>
-          </a:xfrm>
-          <a:prstGeom prst="rect">
-            <a:avLst/>
-          </a:prstGeom>
-          <a:solidFill>
-            <a:srgbClr val="F1F6EC"/>
-          </a:solidFill>
-        </p:spPr>
-        <p:txBody>
-          <a:bodyPr wrap="square" lIns="91440" tIns="91440" rIns="91440" bIns="91440" anchor="ctr"/>
-          <a:lstStyle/>
-          <a:p>
-            <a:pPr>
-              <a:spcAft>
-                <a:spcPts val="900"/>
-              </a:spcAft>
-            </a:pPr>
-            <a:r>
-              <a:rPr sz="1200" b="1" i="0">
-                <a:solidFill>
-                  <a:srgbClr val="97BC62"/>
-                </a:solidFill>
-                <a:latin typeface="Calibri"/>
-              </a:rPr>
-              <a:t>THE AARONIC BLESSING — NUMBERS 6:24–26</a:t>
-            </a:r>
-          </a:p>
-          <a:p>
-            <a:pPr>
-              <a:spcAft>
-                <a:spcPts val="600"/>
-              </a:spcAft>
-            </a:pPr>
-            <a:r>
-              <a:rPr sz="2400" b="0" i="1">
-                <a:solidFill>
-                  <a:srgbClr val="222B22"/>
-                </a:solidFill>
-                <a:latin typeface="Cambria"/>
-              </a:rPr>
-              <a:t>“The Lord bless you and keep you;</a:t>
-            </a:r>
-          </a:p>
-          <a:p>
-            <a:pPr>
-              <a:spcAft>
-                <a:spcPts val="600"/>
-              </a:spcAft>
-            </a:pPr>
-            <a:r>
-              <a:rPr sz="2400" b="0" i="1">
-                <a:solidFill>
-                  <a:srgbClr val="222B22"/>
-                </a:solidFill>
-                <a:latin typeface="Cambria"/>
-              </a:rPr>
-              <a:t>the Lord make his face to shine upon you, and be gracious to you;</a:t>
-            </a:r>
-          </a:p>
-          <a:p>
-            <a:pPr>
-              <a:spcAft>
-                <a:spcPts val="600"/>
-              </a:spcAft>
-            </a:pPr>
-            <a:r>
-              <a:rPr sz="2400" b="0" i="1">
-                <a:solidFill>
-                  <a:srgbClr val="222B22"/>
-                </a:solidFill>
-                <a:latin typeface="Cambria"/>
-              </a:rPr>
-              <a:t>the Lord lift up his countenance upon you, and give you peace.”</a:t>
-            </a:r>
-          </a:p>
-        </p:txBody>
-      </p:sp>
-      <p:sp>
-        <p:nvSpPr>
-          <p:cNvPr id="90" name="SlideNum"/>
-          <p:cNvSpPr txBox="1"/>
-          <p:nvPr/>
-        </p:nvSpPr>
-        <p:spPr>
-          <a:xfrm>
-            <a:off x="11384280" y="6446520"/>
-            <a:ext cx="640080" cy="292608"/>
-          </a:xfrm>
-          <a:prstGeom prst="rect">
-            <a:avLst/>
-          </a:prstGeom>
-          <a:noFill/>
-        </p:spPr>
-        <p:txBody>
-          <a:bodyPr wrap="none" lIns="0" tIns="0" rIns="45720" bIns="0" anchor="ctr"/>
-          <a:lstStyle/>
-          <a:p>
-            <a:pPr algn="r"/>
-            <a:r>
               <a:t>266</a:t>
             </a:r>
             <a:endParaRPr sz="1000" b="1">
@@ -5746,6 +5712,415 @@
                 </a:solidFill>
                 <a:latin typeface="Cambria"/>
               </a:rPr>
+              <a:t>Closing the Container + Aaronic Blessing</a:t>
+            </a:r>
+          </a:p>
+        </p:txBody>
+      </p:sp>
+      <p:sp>
+        <p:nvSpPr>
+          <p:cNvPr id="4" name="TextBox 4"/>
+          <p:cNvSpPr txBox="1"/>
+          <p:nvPr/>
+        </p:nvSpPr>
+        <p:spPr>
+          <a:xfrm>
+            <a:off x="822960" y="1600200"/>
+            <a:ext cx="5669280" cy="4572000"/>
+          </a:xfrm>
+          <a:prstGeom prst="rect">
+            <a:avLst/>
+          </a:prstGeom>
+          <a:noFill/>
+        </p:spPr>
+        <p:txBody>
+          <a:bodyPr wrap="square" lIns="91440" tIns="91440" rIns="91440" bIns="91440"/>
+          <a:lstStyle/>
+          <a:p>
+            <a:pPr marL="274320" indent="-274320">
+              <a:spcAft>
+                <a:spcPts val="900"/>
+              </a:spcAft>
+            </a:pPr>
+            <a:r>
+              <a:rPr sz="2200" b="1" i="0">
+                <a:solidFill>
+                  <a:srgbClr val="97BC62"/>
+                </a:solidFill>
+                <a:latin typeface="Calibri"/>
+              </a:rPr>
+              <a:t>•  </a:t>
+            </a:r>
+            <a:r>
+              <a:rPr sz="2200" b="0" i="0">
+                <a:solidFill>
+                  <a:srgbClr val="222B22"/>
+                </a:solidFill>
+                <a:latin typeface="Calibri"/>
+              </a:rPr>
+              <a:t>We close the way we opened — the container, six steps:</a:t>
+            </a:r>
+          </a:p>
+          <a:p>
+            <a:pPr marL="685800" indent="-274320">
+              <a:spcAft>
+                <a:spcPts val="700"/>
+              </a:spcAft>
+            </a:pPr>
+            <a:r>
+              <a:rPr sz="2000" b="1" i="0">
+                <a:solidFill>
+                  <a:srgbClr val="97BC62"/>
+                </a:solidFill>
+                <a:latin typeface="Calibri"/>
+              </a:rPr>
+              <a:t>1   </a:t>
+            </a:r>
+            <a:r>
+              <a:rPr sz="2000" b="0" i="0">
+                <a:solidFill>
+                  <a:srgbClr val="222B22"/>
+                </a:solidFill>
+                <a:latin typeface="Calibri"/>
+              </a:rPr>
+              <a:t>Stand again — same circle, same posture as the open</a:t>
+            </a:r>
+          </a:p>
+          <a:p>
+            <a:pPr marL="685800" indent="-274320">
+              <a:spcAft>
+                <a:spcPts val="700"/>
+              </a:spcAft>
+            </a:pPr>
+            <a:r>
+              <a:rPr sz="2000" b="1" i="0">
+                <a:solidFill>
+                  <a:srgbClr val="97BC62"/>
+                </a:solidFill>
+                <a:latin typeface="Calibri"/>
+              </a:rPr>
+              <a:t>2   </a:t>
+            </a:r>
+            <a:r>
+              <a:rPr sz="2000" b="0" i="0">
+                <a:solidFill>
+                  <a:srgbClr val="222B22"/>
+                </a:solidFill>
+                <a:latin typeface="Calibri"/>
+              </a:rPr>
+              <a:t>One-word landing — compare it to your opening word</a:t>
+            </a:r>
+          </a:p>
+          <a:p>
+            <a:pPr marL="685800" indent="-274320">
+              <a:spcAft>
+                <a:spcPts val="700"/>
+              </a:spcAft>
+            </a:pPr>
+            <a:r>
+              <a:rPr sz="2000" b="1" i="0">
+                <a:solidFill>
+                  <a:srgbClr val="97BC62"/>
+                </a:solidFill>
+                <a:latin typeface="Calibri"/>
+              </a:rPr>
+              <a:t>3   </a:t>
+            </a:r>
+            <a:r>
+              <a:rPr sz="2000" b="0" i="0">
+                <a:solidFill>
+                  <a:srgbClr val="222B22"/>
+                </a:solidFill>
+                <a:latin typeface="Calibri"/>
+              </a:rPr>
+              <a:t>The one thing you are taking from tonight</a:t>
+            </a:r>
+          </a:p>
+          <a:p>
+            <a:pPr marL="685800" indent="-274320">
+              <a:spcAft>
+                <a:spcPts val="700"/>
+              </a:spcAft>
+            </a:pPr>
+            <a:r>
+              <a:rPr sz="2000" b="1" i="0">
+                <a:solidFill>
+                  <a:srgbClr val="97BC62"/>
+                </a:solidFill>
+                <a:latin typeface="Calibri"/>
+              </a:rPr>
+              <a:t>4   </a:t>
+            </a:r>
+            <a:r>
+              <a:rPr sz="2000" b="0" i="0">
+                <a:solidFill>
+                  <a:srgbClr val="222B22"/>
+                </a:solidFill>
+                <a:latin typeface="Calibri"/>
+              </a:rPr>
+              <a:t>The one practice — committed aloud, or modified to one you will actually keep</a:t>
+            </a:r>
+          </a:p>
+          <a:p>
+            <a:pPr marL="685800" indent="-274320">
+              <a:spcAft>
+                <a:spcPts val="700"/>
+              </a:spcAft>
+            </a:pPr>
+            <a:r>
+              <a:rPr sz="2000" b="1" i="0">
+                <a:solidFill>
+                  <a:srgbClr val="97BC62"/>
+                </a:solidFill>
+                <a:latin typeface="Calibri"/>
+              </a:rPr>
+              <a:t>5   </a:t>
+            </a:r>
+            <a:r>
+              <a:rPr sz="2000" b="0" i="0">
+                <a:solidFill>
+                  <a:srgbClr val="222B22"/>
+                </a:solidFill>
+                <a:latin typeface="Calibri"/>
+              </a:rPr>
+              <a:t>Blessings — eyes on the person, not the screen: say what is on your heart for them. Specific, witnessed, short</a:t>
+            </a:r>
+          </a:p>
+          <a:p>
+            <a:pPr marL="685800" indent="-274320">
+              <a:spcAft>
+                <a:spcPts val="700"/>
+              </a:spcAft>
+            </a:pPr>
+            <a:r>
+              <a:rPr sz="2000" b="1" i="0">
+                <a:solidFill>
+                  <a:srgbClr val="97BC62"/>
+                </a:solidFill>
+                <a:latin typeface="Calibri"/>
+              </a:rPr>
+              <a:t>6   </a:t>
+            </a:r>
+            <a:r>
+              <a:rPr sz="2000" b="0" i="0">
+                <a:solidFill>
+                  <a:srgbClr val="222B22"/>
+                </a:solidFill>
+                <a:latin typeface="Calibri"/>
+              </a:rPr>
+              <a:t>Closing prayer — and the Aaronic blessing, spoken over each other, face to face</a:t>
+            </a:r>
+          </a:p>
+        </p:txBody>
+      </p:sp>
+      <p:sp>
+        <p:nvSpPr>
+          <p:cNvPr id="6" name="TextBox 6"/>
+          <p:cNvSpPr txBox="1"/>
+          <p:nvPr/>
+        </p:nvSpPr>
+        <p:spPr>
+          <a:xfrm>
+            <a:off x="6766560" y="1737360"/>
+            <a:ext cx="4663440" cy="2926080"/>
+          </a:xfrm>
+          <a:prstGeom prst="rect">
+            <a:avLst/>
+          </a:prstGeom>
+          <a:solidFill>
+            <a:srgbClr val="F1F6EC"/>
+          </a:solidFill>
+        </p:spPr>
+        <p:txBody>
+          <a:bodyPr wrap="square" lIns="91440" tIns="91440" rIns="91440" bIns="91440" anchor="ctr"/>
+          <a:lstStyle/>
+          <a:p>
+            <a:pPr>
+              <a:spcAft>
+                <a:spcPts val="900"/>
+              </a:spcAft>
+            </a:pPr>
+            <a:r>
+              <a:rPr sz="1200" b="1" i="0">
+                <a:solidFill>
+                  <a:srgbClr val="97BC62"/>
+                </a:solidFill>
+                <a:latin typeface="Calibri"/>
+              </a:rPr>
+              <a:t>THE AARONIC BLESSING — NUMBERS 6:24–26</a:t>
+            </a:r>
+          </a:p>
+          <a:p>
+            <a:pPr>
+              <a:spcAft>
+                <a:spcPts val="600"/>
+              </a:spcAft>
+            </a:pPr>
+            <a:r>
+              <a:rPr sz="2400" b="0" i="1">
+                <a:solidFill>
+                  <a:srgbClr val="222B22"/>
+                </a:solidFill>
+                <a:latin typeface="Cambria"/>
+              </a:rPr>
+              <a:t>“The Lord bless you and keep you;</a:t>
+            </a:r>
+          </a:p>
+          <a:p>
+            <a:pPr>
+              <a:spcAft>
+                <a:spcPts val="600"/>
+              </a:spcAft>
+            </a:pPr>
+            <a:r>
+              <a:rPr sz="2400" b="0" i="1">
+                <a:solidFill>
+                  <a:srgbClr val="222B22"/>
+                </a:solidFill>
+                <a:latin typeface="Cambria"/>
+              </a:rPr>
+              <a:t>the Lord make his face to shine upon you, and be gracious to you;</a:t>
+            </a:r>
+          </a:p>
+          <a:p>
+            <a:pPr>
+              <a:spcAft>
+                <a:spcPts val="600"/>
+              </a:spcAft>
+            </a:pPr>
+            <a:r>
+              <a:rPr sz="2400" b="0" i="1">
+                <a:solidFill>
+                  <a:srgbClr val="222B22"/>
+                </a:solidFill>
+                <a:latin typeface="Cambria"/>
+              </a:rPr>
+              <a:t>the Lord lift up his countenance upon you, and give you peace.”</a:t>
+            </a:r>
+          </a:p>
+        </p:txBody>
+      </p:sp>
+      <p:sp>
+        <p:nvSpPr>
+          <p:cNvPr id="90" name="SlideNum"/>
+          <p:cNvSpPr txBox="1"/>
+          <p:nvPr/>
+        </p:nvSpPr>
+        <p:spPr>
+          <a:xfrm>
+            <a:off x="11384280" y="6446520"/>
+            <a:ext cx="640080" cy="292608"/>
+          </a:xfrm>
+          <a:prstGeom prst="rect">
+            <a:avLst/>
+          </a:prstGeom>
+          <a:noFill/>
+        </p:spPr>
+        <p:txBody>
+          <a:bodyPr wrap="none" lIns="0" tIns="0" rIns="45720" bIns="0" anchor="ctr"/>
+          <a:lstStyle/>
+          <a:p>
+            <a:pPr algn="r"/>
+            <a:r>
+              <a:t>267</a:t>
+            </a:r>
+            <a:endParaRPr sz="1000" b="1">
+              <a:solidFill>
+                <a:srgbClr val="7A8A6E"/>
+              </a:solidFill>
+              <a:latin typeface="Calibri"/>
+            </a:endParaRPr>
+          </a:p>
+        </p:txBody>
+      </p:sp>
+    </p:spTree>
+  </p:cSld>
+  <p:clrMapOvr>
+    <a:masterClrMapping/>
+  </p:clrMapOvr>
+</p:sld>
+</file>
+
+<file path=ppt/slides/slide14.xml><?xml version="1.0" encoding="utf-8"?>
+<p:sld xmlns:a="http://schemas.openxmlformats.org/drawingml/2006/main" xmlns:r="http://schemas.openxmlformats.org/officeDocument/2006/relationships" xmlns:p="http://schemas.openxmlformats.org/presentationml/2006/main">
+  <p:cSld>
+    <p:spTree>
+      <p:nvGrpSpPr>
+        <p:cNvPr id="1" name=""/>
+        <p:cNvGrpSpPr/>
+        <p:nvPr/>
+      </p:nvGrpSpPr>
+      <p:grpSpPr>
+        <a:xfrm>
+          <a:off x="0" y="0"/>
+          <a:ext cx="0" cy="0"/>
+          <a:chOff x="0" y="0"/>
+          <a:chExt cx="0" cy="0"/>
+        </a:xfrm>
+      </p:grpSpPr>
+      <p:sp>
+        <p:nvSpPr>
+          <p:cNvPr id="2" name="Rectangle 1"/>
+          <p:cNvSpPr/>
+          <p:nvPr/>
+        </p:nvSpPr>
+        <p:spPr>
+          <a:xfrm>
+            <a:off x="0" y="0"/>
+            <a:ext cx="12191695" cy="6858000"/>
+          </a:xfrm>
+          <a:prstGeom prst="rect">
+            <a:avLst/>
+          </a:prstGeom>
+          <a:solidFill>
+            <a:srgbClr val="FFFFFF"/>
+          </a:solidFill>
+          <a:ln>
+            <a:noFill/>
+          </a:ln>
+        </p:spPr>
+        <p:txBody>
+          <a:bodyPr/>
+          <a:lstStyle/>
+          <a:p>
+            <a:endParaRPr/>
+          </a:p>
+        </p:txBody>
+      </p:sp>
+      <p:sp>
+        <p:nvSpPr>
+          <p:cNvPr id="3" name="TextBox 2"/>
+          <p:cNvSpPr txBox="1"/>
+          <p:nvPr/>
+        </p:nvSpPr>
+        <p:spPr>
+          <a:xfrm>
+            <a:off x="822960" y="502920"/>
+            <a:ext cx="10515600" cy="822960"/>
+          </a:xfrm>
+          <a:prstGeom prst="rect">
+            <a:avLst/>
+          </a:prstGeom>
+          <a:noFill/>
+        </p:spPr>
+        <p:txBody>
+          <a:bodyPr wrap="square">
+            <a:spAutoFit/>
+          </a:bodyPr>
+          <a:lstStyle/>
+          <a:p>
+            <a:pPr algn="l">
+              <a:spcAft>
+                <a:spcPts val="600"/>
+              </a:spcAft>
+            </a:pPr>
+            <a:r>
+              <a:rPr sz="2800" b="1" i="0">
+                <a:solidFill>
+                  <a:srgbClr val="2C5F2D"/>
+                </a:solidFill>
+                <a:latin typeface="Cambria"/>
+              </a:rPr>
               <a:t>The Leader Feedback Round</a:t>
             </a:r>
           </a:p>
@@ -5944,7 +6319,7 @@
           <a:p>
             <a:pPr algn="r"/>
             <a:r>
-              <a:t>267</a:t>
+              <a:t>268</a:t>
             </a:r>
             <a:endParaRPr sz="1000" b="1">
               <a:solidFill>
@@ -5999,7 +6374,7 @@
 </p:sld>
 </file>
 
-<file path=ppt/slides/slide14.xml><?xml version="1.0" encoding="utf-8"?>
+<file path=ppt/slides/slide15.xml><?xml version="1.0" encoding="utf-8"?>
 <p:sld xmlns:a="http://schemas.openxmlformats.org/drawingml/2006/main" xmlns:r="http://schemas.openxmlformats.org/officeDocument/2006/relationships" xmlns:p="http://schemas.openxmlformats.org/presentationml/2006/main">
   <p:cSld>
     <p:spTree>
@@ -6257,7 +6632,7 @@
           <a:p>
             <a:pPr algn="r"/>
             <a:r>
-              <a:t>268</a:t>
+              <a:t>269</a:t>
             </a:r>
             <a:endParaRPr sz="1000" b="1">
               <a:solidFill>
@@ -6859,7 +7234,7 @@
               </a:spcAft>
             </a:pPr>
             <a:r>
-              <a:rPr sz="2800" b="1">
+              <a:rPr sz="2400" b="1">
                 <a:solidFill>
                   <a:srgbClr val="97BC62"/>
                 </a:solidFill>
@@ -6868,7 +7243,7 @@
               <a:t>1   </a:t>
             </a:r>
             <a:r>
-              <a:rPr sz="2800">
+              <a:rPr sz="2400">
                 <a:solidFill>
                   <a:srgbClr val="222B22"/>
                 </a:solidFill>
@@ -6884,7 +7259,7 @@
               </a:spcAft>
             </a:pPr>
             <a:r>
-              <a:rPr sz="2800" b="1">
+              <a:rPr sz="2400" b="1">
                 <a:solidFill>
                   <a:srgbClr val="97BC62"/>
                 </a:solidFill>
@@ -6893,7 +7268,7 @@
               <a:t>2   </a:t>
             </a:r>
             <a:r>
-              <a:rPr sz="2800">
+              <a:rPr sz="2400">
                 <a:solidFill>
                   <a:srgbClr val="222B22"/>
                 </a:solidFill>
@@ -6909,7 +7284,7 @@
               </a:spcAft>
             </a:pPr>
             <a:r>
-              <a:rPr sz="2800" b="1">
+              <a:rPr sz="2400" b="1">
                 <a:solidFill>
                   <a:srgbClr val="97BC62"/>
                 </a:solidFill>
@@ -6918,7 +7293,7 @@
               <a:t>3   </a:t>
             </a:r>
             <a:r>
-              <a:rPr sz="2800">
+              <a:rPr sz="2400">
                 <a:solidFill>
                   <a:srgbClr val="222B22"/>
                 </a:solidFill>
@@ -6934,7 +7309,7 @@
               </a:spcAft>
             </a:pPr>
             <a:r>
-              <a:rPr sz="2800" b="1">
+              <a:rPr sz="2400" b="1">
                 <a:solidFill>
                   <a:srgbClr val="97BC62"/>
                 </a:solidFill>
@@ -6943,7 +7318,7 @@
               <a:t>4   </a:t>
             </a:r>
             <a:r>
-              <a:rPr sz="2800">
+              <a:rPr sz="2400">
                 <a:solidFill>
                   <a:srgbClr val="222B22"/>
                 </a:solidFill>
@@ -6959,7 +7334,7 @@
               </a:spcAft>
             </a:pPr>
             <a:r>
-              <a:rPr sz="2800" b="1">
+              <a:rPr sz="2400" b="1">
                 <a:solidFill>
                   <a:srgbClr val="97BC62"/>
                 </a:solidFill>
@@ -6968,13 +7343,13 @@
               <a:t>5   </a:t>
             </a:r>
             <a:r>
-              <a:rPr sz="2800">
+              <a:rPr sz="2400">
                 <a:solidFill>
                   <a:srgbClr val="222B22"/>
                 </a:solidFill>
                 <a:latin typeface="Calibri"/>
               </a:rPr>
-              <a:t>Homework commissioning — handout + check-in partners</a:t>
+              <a:t>Ready, and not yet</a:t>
             </a:r>
           </a:p>
           <a:p>
@@ -6984,7 +7359,7 @@
               </a:spcAft>
             </a:pPr>
             <a:r>
-              <a:rPr sz="2800" b="1">
+              <a:rPr sz="2400" b="1">
                 <a:solidFill>
                   <a:srgbClr val="97BC62"/>
                 </a:solidFill>
@@ -6993,13 +7368,13 @@
               <a:t>6   </a:t>
             </a:r>
             <a:r>
-              <a:rPr sz="2800">
+              <a:rPr sz="2400">
                 <a:solidFill>
                   <a:srgbClr val="222B22"/>
                 </a:solidFill>
                 <a:latin typeface="Calibri"/>
               </a:rPr>
-              <a:t>Closing container</a:t>
+              <a:t>Homework — handout + check-in partners</a:t>
             </a:r>
           </a:p>
           <a:p>
@@ -7009,7 +7384,7 @@
               </a:spcAft>
             </a:pPr>
             <a:r>
-              <a:rPr sz="2800" b="1">
+              <a:rPr sz="2400" b="1">
                 <a:solidFill>
                   <a:srgbClr val="97BC62"/>
                 </a:solidFill>
@@ -7018,13 +7393,13 @@
               <a:t>7   </a:t>
             </a:r>
             <a:r>
-              <a:rPr sz="2800">
+              <a:rPr sz="2400">
                 <a:solidFill>
                   <a:srgbClr val="222B22"/>
                 </a:solidFill>
                 <a:latin typeface="Calibri"/>
               </a:rPr>
-              <a:t>Leader Feedback Round</a:t>
+              <a:t>Closing container</a:t>
             </a:r>
           </a:p>
           <a:p>
@@ -7034,7 +7409,7 @@
               </a:spcAft>
             </a:pPr>
             <a:r>
-              <a:rPr sz="2800" b="1">
+              <a:rPr sz="2400" b="1">
                 <a:solidFill>
                   <a:srgbClr val="97BC62"/>
                 </a:solidFill>
@@ -7043,7 +7418,32 @@
               <a:t>8   </a:t>
             </a:r>
             <a:r>
-              <a:rPr sz="2800">
+              <a:rPr sz="2400">
+                <a:solidFill>
+                  <a:srgbClr val="222B22"/>
+                </a:solidFill>
+                <a:latin typeface="Calibri"/>
+              </a:rPr>
+              <a:t>Leader Feedback Round</a:t>
+            </a:r>
+          </a:p>
+          <a:p>
+            <a:pPr>
+              <a:spcAft>
+                <a:spcPts val="800"/>
+              </a:spcAft>
+            </a:pPr>
+            <a:r>
+              <a:rPr sz="2400" b="1">
+                <a:solidFill>
+                  <a:srgbClr val="97BC62"/>
+                </a:solidFill>
+                <a:latin typeface="Calibri"/>
+              </a:rPr>
+              <a:t>9   </a:t>
+            </a:r>
+            <a:r>
+              <a:rPr sz="2400">
                 <a:solidFill>
                   <a:srgbClr val="222B22"/>
                 </a:solidFill>
@@ -8433,7 +8833,7 @@
 </file>
 
 <file path=ppt/slides/slide9.xml><?xml version="1.0" encoding="utf-8"?>
-<p:sld xmlns:a="http://schemas.openxmlformats.org/drawingml/2006/main" xmlns:r="http://schemas.openxmlformats.org/officeDocument/2006/relationships" xmlns:p="http://schemas.openxmlformats.org/presentationml/2006/main">
+<p:sld xmlns:a="http://schemas.openxmlformats.org/drawingml/2006/main" xmlns:p="http://schemas.openxmlformats.org/presentationml/2006/main" xmlns:r="http://schemas.openxmlformats.org/officeDocument/2006/relationships">
   <p:cSld>
     <p:spTree>
       <p:nvGrpSpPr>
@@ -8441,14 +8841,7 @@
         <p:cNvGrpSpPr/>
         <p:nvPr/>
       </p:nvGrpSpPr>
-      <p:grpSpPr>
-        <a:xfrm>
-          <a:off x="0" y="0"/>
-          <a:ext cx="0" cy="0"/>
-          <a:chOff x="0" y="0"/>
-          <a:chExt cx="0" cy="0"/>
-        </a:xfrm>
-      </p:grpSpPr>
+      <p:grpSpPr/>
       <p:sp>
         <p:nvSpPr>
           <p:cNvPr id="2" name="Rectangle 1"/>
@@ -8512,7 +8905,7 @@
                 </a:solidFill>
                 <a:latin typeface="Cambria"/>
               </a:rPr>
-              <a:t>Homework — Two Weeks, Four Parts</a:t>
+              <a:t>Ready, and Not Yet</a:t>
             </a:r>
           </a:p>
         </p:txBody>
@@ -8526,7 +8919,7 @@
         <p:spPr>
           <a:xfrm>
             <a:off x="822960" y="1554480"/>
-            <a:ext cx="6675120" cy="4892040"/>
+            <a:ext cx="10515600" cy="4892040"/>
           </a:xfrm>
           <a:prstGeom prst="rect">
             <a:avLst/>
@@ -8537,9 +8930,84 @@
           <a:bodyPr wrap="square" lIns="91440" tIns="91440" rIns="91440" bIns="91440"/>
           <a:lstStyle/>
           <a:p>
+            <a:pPr marL="342900" indent="-342900">
+              <a:spcAft>
+                <a:spcPts val="750"/>
+              </a:spcAft>
+            </a:pPr>
+            <a:r>
+              <a:rPr sz="2200" b="1" i="0">
+                <a:solidFill>
+                  <a:srgbClr val="97BC62"/>
+                </a:solidFill>
+                <a:latin typeface="Calibri"/>
+              </a:rPr>
+              <a:t>1   </a:t>
+            </a:r>
+            <a:r>
+              <a:rPr sz="2200" b="0" i="0">
+                <a:solidFill>
+                  <a:srgbClr val="222B22"/>
+                </a:solidFill>
+                <a:latin typeface="Calibri"/>
+              </a:rPr>
+              <a:t>Write (3 min): What can I do now, on my own, that I couldn’t when we started?</a:t>
+            </a:r>
+          </a:p>
+          <a:p>
+            <a:pPr marL="342900" indent="-342900">
+              <a:spcAft>
+                <a:spcPts val="750"/>
+              </a:spcAft>
+            </a:pPr>
+            <a:r>
+              <a:rPr sz="2200" b="1" i="0">
+                <a:solidFill>
+                  <a:srgbClr val="97BC62"/>
+                </a:solidFill>
+                <a:latin typeface="Calibri"/>
+              </a:rPr>
+              <a:t>2   </a:t>
+            </a:r>
+            <a:r>
+              <a:rPr sz="2200" b="0" i="0">
+                <a:solidFill>
+                  <a:srgbClr val="222B22"/>
+                </a:solidFill>
+                <a:latin typeface="Calibri"/>
+              </a:rPr>
+              <a:t>Where do I still need someone beside me — a parent, an adult, this group?</a:t>
+            </a:r>
+          </a:p>
+          <a:p>
+            <a:pPr marL="342900" indent="-342900">
+              <a:spcAft>
+                <a:spcPts val="750"/>
+              </a:spcAft>
+            </a:pPr>
+            <a:r>
+              <a:rPr sz="2200" b="1" i="0">
+                <a:solidFill>
+                  <a:srgbClr val="97BC62"/>
+                </a:solidFill>
+                <a:latin typeface="Calibri"/>
+              </a:rPr>
+              <a:t>3   </a:t>
+            </a:r>
+            <a:r>
+              <a:rPr sz="2200" b="0" i="0">
+                <a:solidFill>
+                  <a:srgbClr val="222B22"/>
+                </a:solidFill>
+                <a:latin typeface="Calibri"/>
+              </a:rPr>
+              <a:t>What would help me move one “not yet” toward ready before we are sent?</a:t>
+            </a:r>
+          </a:p>
+          <a:p>
             <a:pPr marL="274320" indent="-274320">
               <a:spcAft>
-                <a:spcPts val="900"/>
+                <a:spcPts val="750"/>
               </a:spcAft>
             </a:pPr>
             <a:r>
@@ -8558,13 +9026,13 @@
                 </a:solidFill>
                 <a:latin typeface="Calibri"/>
               </a:rPr>
-              <a:t>Run your Rhythm Card as built — nothing new, nothing extra; if the break knocked a piece loose, begin again on the next available day</a:t>
+              <a:t>Pairs within families (6 min): the parent answers first. Then the parent names one place they see their teen ready, and one place they still want to walk beside them</a:t>
             </a:r>
           </a:p>
           <a:p>
             <a:pPr marL="274320" indent="-274320">
               <a:spcAft>
-                <a:spcPts val="900"/>
+                <a:spcPts val="750"/>
               </a:spcAft>
             </a:pPr>
             <a:r>
@@ -8583,13 +9051,13 @@
                 </a:solidFill>
                 <a:latin typeface="Calibri"/>
               </a:rPr>
-              <a:t>The evening note, one extra flavor: note where you see God already handing pieces of this year over to you</a:t>
+              <a:t>Room round (3 min): one “ready” each, out loud. The “not yets” stay in the pair</a:t>
             </a:r>
           </a:p>
           <a:p>
             <a:pPr marL="274320" indent="-274320">
               <a:spcAft>
-                <a:spcPts val="900"/>
+                <a:spcPts val="750"/>
               </a:spcAft>
             </a:pPr>
             <a:r>
@@ -8608,32 +9076,7 @@
                 </a:solidFill>
                 <a:latin typeface="Calibri"/>
               </a:rPr>
-              <a:t>For the parents, said once: the Four Questions door is still open — willing-only, whenever the moment is right; nobody will ever check. The questions keep</a:t>
-            </a:r>
-          </a:p>
-          <a:p>
-            <a:pPr marL="274320" indent="-274320">
-              <a:spcAft>
-                <a:spcPts val="900"/>
-              </a:spcAft>
-            </a:pPr>
-            <a:r>
-              <a:rPr sz="2200" b="1" i="0">
-                <a:solidFill>
-                  <a:srgbClr val="97BC62"/>
-                </a:solidFill>
-                <a:latin typeface="Calibri"/>
-              </a:rPr>
-              <a:t>•  </a:t>
-            </a:r>
-            <a:r>
-              <a:rPr sz="2200" b="0" i="0">
-                <a:solidFill>
-                  <a:srgbClr val="222B22"/>
-                </a:solidFill>
-                <a:latin typeface="Calibri"/>
-              </a:rPr>
-              <a:t>Bring your journal — and put Evening 16's two hours on the calendar tonight</a:t>
+              <a:t>“Not yet” is an honest answer, not a failure</a:t>
             </a:r>
           </a:p>
         </p:txBody>
@@ -8671,42 +9114,6 @@
           </a:p>
         </p:txBody>
       </p:sp>
-      <p:pic>
-        <p:nvPicPr>
-          <p:cNvPr id="33" name="Picture 33" descr="seedling - what grows between Wednesdays"/>
-          <p:cNvPicPr>
-            <a:picLocks noChangeAspect="1"/>
-          </p:cNvPicPr>
-          <p:nvPr/>
-        </p:nvPicPr>
-        <p:blipFill>
-          <a:blip r:embed="rId3"/>
-          <a:stretch>
-            <a:fillRect/>
-          </a:stretch>
-        </p:blipFill>
-        <p:spPr>
-          <a:xfrm>
-            <a:off x="8103612" y="1463040"/>
-            <a:ext cx="3262379" cy="4892040"/>
-          </a:xfrm>
-          <a:prstGeom prst="rect">
-            <a:avLst/>
-          </a:prstGeom>
-          <a:ln w="76200">
-            <a:solidFill>
-              <a:srgbClr val="FFFFFF"/>
-            </a:solidFill>
-          </a:ln>
-          <a:effectLst>
-            <a:outerShdw blurRad="63500" dist="25400" dir="5400000" rotWithShape="0">
-              <a:srgbClr val="000000">
-                <a:alpha val="35000"/>
-              </a:srgbClr>
-            </a:outerShdw>
-          </a:effectLst>
-        </p:spPr>
-      </p:pic>
     </p:spTree>
   </p:cSld>
   <p:clrMapOvr>

</xml_diff>